<commit_message>
숙제 3-5, 3-7 완료
</commit_message>
<xml_diff>
--- a/문제해결프로그래밍_숙제/제출용/숙제3_2022182035.pptx
+++ b/문제해결프로그래밍_숙제/제출용/숙제3_2022182035.pptx
@@ -34873,6 +34873,66 @@
           </a:p>
         </p:txBody>
       </p:sp>
+      <p:pic>
+        <p:nvPicPr>
+          <p:cNvPr id="3" name="그림 2">
+            <a:extLst>
+              <a:ext uri="{FF2B5EF4-FFF2-40B4-BE49-F238E27FC236}">
+                <a16:creationId xmlns:a16="http://schemas.microsoft.com/office/drawing/2014/main" id="{B171B698-E71E-42AA-A2A8-B9160B2D8036}"/>
+              </a:ext>
+            </a:extLst>
+          </p:cNvPr>
+          <p:cNvPicPr>
+            <a:picLocks noChangeAspect="1"/>
+          </p:cNvPicPr>
+          <p:nvPr/>
+        </p:nvPicPr>
+        <p:blipFill>
+          <a:blip r:embed="rId3"/>
+          <a:stretch>
+            <a:fillRect/>
+          </a:stretch>
+        </p:blipFill>
+        <p:spPr>
+          <a:xfrm>
+            <a:off x="722388" y="1036864"/>
+            <a:ext cx="3229883" cy="3829050"/>
+          </a:xfrm>
+          <a:prstGeom prst="rect">
+            <a:avLst/>
+          </a:prstGeom>
+        </p:spPr>
+      </p:pic>
+      <p:pic>
+        <p:nvPicPr>
+          <p:cNvPr id="5" name="그림 4">
+            <a:extLst>
+              <a:ext uri="{FF2B5EF4-FFF2-40B4-BE49-F238E27FC236}">
+                <a16:creationId xmlns:a16="http://schemas.microsoft.com/office/drawing/2014/main" id="{DE59C112-B08C-70DB-5FD4-4E36F4EAD42B}"/>
+              </a:ext>
+            </a:extLst>
+          </p:cNvPr>
+          <p:cNvPicPr>
+            <a:picLocks noChangeAspect="1"/>
+          </p:cNvPicPr>
+          <p:nvPr/>
+        </p:nvPicPr>
+        <p:blipFill>
+          <a:blip r:embed="rId4"/>
+          <a:stretch>
+            <a:fillRect/>
+          </a:stretch>
+        </p:blipFill>
+        <p:spPr>
+          <a:xfrm>
+            <a:off x="4233767" y="1424667"/>
+            <a:ext cx="4187821" cy="3043556"/>
+          </a:xfrm>
+          <a:prstGeom prst="rect">
+            <a:avLst/>
+          </a:prstGeom>
+        </p:spPr>
+      </p:pic>
     </p:spTree>
     <p:extLst>
       <p:ext uri="{BB962C8B-B14F-4D97-AF65-F5344CB8AC3E}">
@@ -35179,6 +35239,66 @@
           </a:p>
         </p:txBody>
       </p:sp>
+      <p:pic>
+        <p:nvPicPr>
+          <p:cNvPr id="3" name="그림 2">
+            <a:extLst>
+              <a:ext uri="{FF2B5EF4-FFF2-40B4-BE49-F238E27FC236}">
+                <a16:creationId xmlns:a16="http://schemas.microsoft.com/office/drawing/2014/main" id="{51EF1305-9D8E-9B5F-DCCE-C4CA50B7AB2D}"/>
+              </a:ext>
+            </a:extLst>
+          </p:cNvPr>
+          <p:cNvPicPr>
+            <a:picLocks noChangeAspect="1"/>
+          </p:cNvPicPr>
+          <p:nvPr/>
+        </p:nvPicPr>
+        <p:blipFill>
+          <a:blip r:embed="rId3"/>
+          <a:stretch>
+            <a:fillRect/>
+          </a:stretch>
+        </p:blipFill>
+        <p:spPr>
+          <a:xfrm>
+            <a:off x="1030429" y="935298"/>
+            <a:ext cx="2927394" cy="3845600"/>
+          </a:xfrm>
+          <a:prstGeom prst="rect">
+            <a:avLst/>
+          </a:prstGeom>
+        </p:spPr>
+      </p:pic>
+      <p:pic>
+        <p:nvPicPr>
+          <p:cNvPr id="5" name="그림 4">
+            <a:extLst>
+              <a:ext uri="{FF2B5EF4-FFF2-40B4-BE49-F238E27FC236}">
+                <a16:creationId xmlns:a16="http://schemas.microsoft.com/office/drawing/2014/main" id="{D1DBD29B-37BF-89B8-E3BE-55788B193E72}"/>
+              </a:ext>
+            </a:extLst>
+          </p:cNvPr>
+          <p:cNvPicPr>
+            <a:picLocks noChangeAspect="1"/>
+          </p:cNvPicPr>
+          <p:nvPr/>
+        </p:nvPicPr>
+        <p:blipFill>
+          <a:blip r:embed="rId4"/>
+          <a:stretch>
+            <a:fillRect/>
+          </a:stretch>
+        </p:blipFill>
+        <p:spPr>
+          <a:xfrm>
+            <a:off x="4077242" y="1588715"/>
+            <a:ext cx="4224927" cy="2538767"/>
+          </a:xfrm>
+          <a:prstGeom prst="rect">
+            <a:avLst/>
+          </a:prstGeom>
+        </p:spPr>
+      </p:pic>
     </p:spTree>
     <p:extLst>
       <p:ext uri="{BB962C8B-B14F-4D97-AF65-F5344CB8AC3E}">

</xml_diff>